<commit_message>
feat: reprocessa slides da missa Quaresma I (61 slides)
</commit_message>
<xml_diff>
--- a/missas/Quaresma/Quaresma_I.pptx
+++ b/missas/Quaresma/Quaresma_I.pptx
@@ -56,6 +56,16 @@
     <p:sldId id="304" r:id="rId55"/>
     <p:sldId id="305" r:id="rId56"/>
     <p:sldId id="306" r:id="rId57"/>
+    <p:sldId id="307" r:id="rId58"/>
+    <p:sldId id="308" r:id="rId59"/>
+    <p:sldId id="309" r:id="rId60"/>
+    <p:sldId id="310" r:id="rId61"/>
+    <p:sldId id="311" r:id="rId62"/>
+    <p:sldId id="312" r:id="rId63"/>
+    <p:sldId id="313" r:id="rId64"/>
+    <p:sldId id="314" r:id="rId65"/>
+    <p:sldId id="315" r:id="rId66"/>
+    <p:sldId id="316" r:id="rId67"/>
   </p:sldIdLst>
   <p:sldSz cx="12191695" cy="6858000" type="screen4x3"/>
   <p:notesSz cx="6858000" cy="9144000"/>
@@ -3231,7 +3241,7 @@
                   <a:srgbClr val="1A1A1A"/>
                 </a:solidFill>
               </a:rPr>
-              <a:t>Kyrie eleison, Kyrie eleison.</a:t>
+              <a:t>Feliz aquele a quem o Senhor perdoa o pecado. Feliz aquele a quem o Senhor perdoa o pecado.</a:t>
             </a:r>
           </a:p>
         </p:txBody>
@@ -3250,7 +3260,7 @@
     <p:bg>
       <p:bgPr>
         <a:solidFill>
-          <a:srgbClr val="FAF9F7"/>
+          <a:srgbClr val="000000"/>
         </a:solidFill>
         <a:effectLst/>
       </p:bgPr>
@@ -3262,39 +3272,6 @@
         <p:nvPr/>
       </p:nvGrpSpPr>
       <p:grpSpPr/>
-      <p:sp>
-        <p:nvSpPr>
-          <p:cNvPr id="2" name="TextBox 1"/>
-          <p:cNvSpPr txBox="1"/>
-          <p:nvPr/>
-        </p:nvSpPr>
-        <p:spPr>
-          <a:xfrm>
-            <a:off x="731520" y="731520"/>
-            <a:ext cx="10728655" cy="5394960"/>
-          </a:xfrm>
-          <a:prstGeom prst="rect">
-            <a:avLst/>
-          </a:prstGeom>
-          <a:noFill/>
-        </p:spPr>
-        <p:txBody>
-          <a:bodyPr wrap="square" anchor="ctr"/>
-          <a:lstStyle/>
-          <a:p>
-            <a:pPr algn="ctr"/>
-            <a:r>
-              <a:rPr sz="3200" b="0" i="0">
-                <a:solidFill>
-                  <a:srgbClr val="444444"/>
-                </a:solidFill>
-              </a:rPr>
-              <a:t>Não sei amar, Senhor, tu sabes,
-se não dilatar meu coração com teu espírito de paz.</a:t>
-            </a:r>
-          </a:p>
-        </p:txBody>
-      </p:sp>
     </p:spTree>
   </p:cSld>
   <p:clrMapOvr>
@@ -3329,8 +3306,8 @@
         </p:nvSpPr>
         <p:spPr>
           <a:xfrm>
-            <a:off x="731520" y="731520"/>
-            <a:ext cx="10728655" cy="5394960"/>
+            <a:off x="731520" y="2057400"/>
+            <a:ext cx="10728655" cy="2400300"/>
           </a:xfrm>
           <a:prstGeom prst="rect">
             <a:avLst/>
@@ -3343,12 +3320,12 @@
           <a:p>
             <a:pPr algn="ctr"/>
             <a:r>
-              <a:rPr sz="3600" b="1" i="0">
+              <a:rPr sz="5200" b="1">
                 <a:solidFill>
                   <a:srgbClr val="1A1A1A"/>
                 </a:solidFill>
               </a:rPr>
-              <a:t>Christe eleison, Christe eleison.</a:t>
+              <a:t>Ato Penitencial</a:t>
             </a:r>
           </a:p>
         </p:txBody>
@@ -3406,8 +3383,8 @@
                   <a:srgbClr val="444444"/>
                 </a:solidFill>
               </a:rPr>
-              <a:t>Minha fraqueza transforma-se em pobreza
-com o dom do teu amor, o espírito de alegria.</a:t>
+              <a:t>Ó Deus, meu coração renova em mim,
+com teu espírito, o espírito de santidade. Kyrie eleison</a:t>
             </a:r>
           </a:p>
         </p:txBody>
@@ -3465,7 +3442,7 @@
                   <a:srgbClr val="1A1A1A"/>
                 </a:solidFill>
               </a:rPr>
-              <a:t>Kyrie eleison, Kyrie eleison.</a:t>
+              <a:t>Kyrie eleison.</a:t>
             </a:r>
           </a:p>
         </p:txBody>
@@ -3484,7 +3461,7 @@
     <p:bg>
       <p:bgPr>
         <a:solidFill>
-          <a:srgbClr val="000000"/>
+          <a:srgbClr val="FAF9F7"/>
         </a:solidFill>
         <a:effectLst/>
       </p:bgPr>
@@ -3496,6 +3473,39 @@
         <p:nvPr/>
       </p:nvGrpSpPr>
       <p:grpSpPr/>
+      <p:sp>
+        <p:nvSpPr>
+          <p:cNvPr id="2" name="TextBox 1"/>
+          <p:cNvSpPr txBox="1"/>
+          <p:nvPr/>
+        </p:nvSpPr>
+        <p:spPr>
+          <a:xfrm>
+            <a:off x="731520" y="731520"/>
+            <a:ext cx="10728655" cy="5394960"/>
+          </a:xfrm>
+          <a:prstGeom prst="rect">
+            <a:avLst/>
+          </a:prstGeom>
+          <a:noFill/>
+        </p:spPr>
+        <p:txBody>
+          <a:bodyPr wrap="square" anchor="ctr"/>
+          <a:lstStyle/>
+          <a:p>
+            <a:pPr algn="ctr"/>
+            <a:r>
+              <a:rPr sz="3200" b="0" i="0">
+                <a:solidFill>
+                  <a:srgbClr val="444444"/>
+                </a:solidFill>
+              </a:rPr>
+              <a:t>Não sei amar, Senhor, tu sabes,
+se não dilatar meu coração com teu espírito de paz. Christe eleison</a:t>
+            </a:r>
+          </a:p>
+        </p:txBody>
+      </p:sp>
     </p:spTree>
   </p:cSld>
   <p:clrMapOvr>
@@ -3530,8 +3540,8 @@
         </p:nvSpPr>
         <p:spPr>
           <a:xfrm>
-            <a:off x="731520" y="2057400"/>
-            <a:ext cx="10728655" cy="2400300"/>
+            <a:off x="731520" y="731520"/>
+            <a:ext cx="10728655" cy="5394960"/>
           </a:xfrm>
           <a:prstGeom prst="rect">
             <a:avLst/>
@@ -3544,12 +3554,12 @@
           <a:p>
             <a:pPr algn="ctr"/>
             <a:r>
-              <a:rPr sz="5200" b="1">
+              <a:rPr sz="3600" b="1" i="0">
                 <a:solidFill>
                   <a:srgbClr val="1A1A1A"/>
                 </a:solidFill>
               </a:rPr>
-              <a:t>Aleluia</a:t>
+              <a:t>Christe eleison.</a:t>
             </a:r>
           </a:p>
         </p:txBody>
@@ -3602,13 +3612,13 @@
           <a:p>
             <a:pPr algn="ctr"/>
             <a:r>
-              <a:rPr sz="3600" b="1" i="0">
-                <a:solidFill>
-                  <a:srgbClr val="1A1A1A"/>
+              <a:rPr sz="3200" b="0" i="0">
+                <a:solidFill>
+                  <a:srgbClr val="444444"/>
                 </a:solidFill>
               </a:rPr>
-              <a:t>Glória e louvor a vós, ó Cristo…
-Glória e louvor a vós, ó Cristo…</a:t>
+              <a:t>Minha fraqueza transforma-se em pobreza
+com o dom do teu amor, o espírito de alegria. Kyrie eleison</a:t>
             </a:r>
           </a:p>
         </p:txBody>
@@ -3627,7 +3637,7 @@
     <p:bg>
       <p:bgPr>
         <a:solidFill>
-          <a:srgbClr val="000000"/>
+          <a:srgbClr val="FAF9F7"/>
         </a:solidFill>
         <a:effectLst/>
       </p:bgPr>
@@ -3639,6 +3649,38 @@
         <p:nvPr/>
       </p:nvGrpSpPr>
       <p:grpSpPr/>
+      <p:sp>
+        <p:nvSpPr>
+          <p:cNvPr id="2" name="TextBox 1"/>
+          <p:cNvSpPr txBox="1"/>
+          <p:nvPr/>
+        </p:nvSpPr>
+        <p:spPr>
+          <a:xfrm>
+            <a:off x="731520" y="731520"/>
+            <a:ext cx="10728655" cy="5394960"/>
+          </a:xfrm>
+          <a:prstGeom prst="rect">
+            <a:avLst/>
+          </a:prstGeom>
+          <a:noFill/>
+        </p:spPr>
+        <p:txBody>
+          <a:bodyPr wrap="square" anchor="ctr"/>
+          <a:lstStyle/>
+          <a:p>
+            <a:pPr algn="ctr"/>
+            <a:r>
+              <a:rPr sz="3600" b="1" i="0">
+                <a:solidFill>
+                  <a:srgbClr val="1A1A1A"/>
+                </a:solidFill>
+              </a:rPr>
+              <a:t>Kyrie eleison.</a:t>
+            </a:r>
+          </a:p>
+        </p:txBody>
+      </p:sp>
     </p:spTree>
   </p:cSld>
   <p:clrMapOvr>
@@ -3653,7 +3695,7 @@
     <p:bg>
       <p:bgPr>
         <a:solidFill>
-          <a:srgbClr val="FAF9F7"/>
+          <a:srgbClr val="000000"/>
         </a:solidFill>
         <a:effectLst/>
       </p:bgPr>
@@ -3665,38 +3707,6 @@
         <p:nvPr/>
       </p:nvGrpSpPr>
       <p:grpSpPr/>
-      <p:sp>
-        <p:nvSpPr>
-          <p:cNvPr id="2" name="TextBox 1"/>
-          <p:cNvSpPr txBox="1"/>
-          <p:nvPr/>
-        </p:nvSpPr>
-        <p:spPr>
-          <a:xfrm>
-            <a:off x="731520" y="2057400"/>
-            <a:ext cx="10728655" cy="2400300"/>
-          </a:xfrm>
-          <a:prstGeom prst="rect">
-            <a:avLst/>
-          </a:prstGeom>
-          <a:noFill/>
-        </p:spPr>
-        <p:txBody>
-          <a:bodyPr wrap="square" anchor="ctr"/>
-          <a:lstStyle/>
-          <a:p>
-            <a:pPr algn="ctr"/>
-            <a:r>
-              <a:rPr sz="5200" b="1">
-                <a:solidFill>
-                  <a:srgbClr val="1A1A1A"/>
-                </a:solidFill>
-              </a:rPr>
-              <a:t>Ofertório</a:t>
-            </a:r>
-          </a:p>
-        </p:txBody>
-      </p:sp>
     </p:spTree>
   </p:cSld>
   <p:clrMapOvr>
@@ -3757,8 +3767,8 @@
         </p:nvSpPr>
         <p:spPr>
           <a:xfrm>
-            <a:off x="731520" y="731520"/>
-            <a:ext cx="10728655" cy="5394960"/>
+            <a:off x="731520" y="2057400"/>
+            <a:ext cx="10728655" cy="2400300"/>
           </a:xfrm>
           <a:prstGeom prst="rect">
             <a:avLst/>
@@ -3771,12 +3781,12 @@
           <a:p>
             <a:pPr algn="ctr"/>
             <a:r>
-              <a:rPr sz="3600" b="1" i="0">
+              <a:rPr sz="5200" b="1">
                 <a:solidFill>
                   <a:srgbClr val="1A1A1A"/>
                 </a:solidFill>
               </a:rPr>
-              <a:t>Miserere mei, Domine. Miserere mei, Domine.</a:t>
+              <a:t>Aleluia</a:t>
             </a:r>
           </a:p>
         </p:txBody>
@@ -3829,12 +3839,13 @@
           <a:p>
             <a:pPr algn="ctr"/>
             <a:r>
-              <a:rPr sz="3200" b="0" i="0">
-                <a:solidFill>
-                  <a:srgbClr val="444444"/>
+              <a:rPr sz="3600" b="1" i="0">
+                <a:solidFill>
+                  <a:srgbClr val="1A1A1A"/>
                 </a:solidFill>
               </a:rPr>
-              <a:t>1. Piedade de mim, ó meu Deus, misericórdia. Na imensidão do amor, purificai-me. Lavai-me todo inteiro do pecado, apagai totalmente minha culpa.2. Eu reconheço toda a minha iniquidade, o meu pecado está sempre à minha frente. Foi contra vós somente que eu pequei e pratiquei o que é mau aos vossos olhos.3. Criai em mim um coração que seja puro, dai-me de novo um espírito firme. Meu sacrifício é minha alma penitente, não desprezeis um coração arrependido.</a:t>
+              <a:t>Glória e louvor a vós, ó Cristo…
+Glória e louvor a vós, ó Cristo…</a:t>
             </a:r>
           </a:p>
         </p:txBody>
@@ -3853,7 +3864,7 @@
     <p:bg>
       <p:bgPr>
         <a:solidFill>
-          <a:srgbClr val="FAF9F7"/>
+          <a:srgbClr val="000000"/>
         </a:solidFill>
         <a:effectLst/>
       </p:bgPr>
@@ -3865,38 +3876,6 @@
         <p:nvPr/>
       </p:nvGrpSpPr>
       <p:grpSpPr/>
-      <p:sp>
-        <p:nvSpPr>
-          <p:cNvPr id="2" name="TextBox 1"/>
-          <p:cNvSpPr txBox="1"/>
-          <p:nvPr/>
-        </p:nvSpPr>
-        <p:spPr>
-          <a:xfrm>
-            <a:off x="731520" y="731520"/>
-            <a:ext cx="10728655" cy="5394960"/>
-          </a:xfrm>
-          <a:prstGeom prst="rect">
-            <a:avLst/>
-          </a:prstGeom>
-          <a:noFill/>
-        </p:spPr>
-        <p:txBody>
-          <a:bodyPr wrap="square" anchor="ctr"/>
-          <a:lstStyle/>
-          <a:p>
-            <a:pPr algn="ctr"/>
-            <a:r>
-              <a:rPr sz="3600" b="1" i="0">
-                <a:solidFill>
-                  <a:srgbClr val="1A1A1A"/>
-                </a:solidFill>
-              </a:rPr>
-              <a:t>Miserere mei, Domine. Miserere mei, Domine.</a:t>
-            </a:r>
-          </a:p>
-        </p:txBody>
-      </p:sp>
     </p:spTree>
   </p:cSld>
   <p:clrMapOvr>
@@ -3911,7 +3890,7 @@
     <p:bg>
       <p:bgPr>
         <a:solidFill>
-          <a:srgbClr val="000000"/>
+          <a:srgbClr val="FAF9F7"/>
         </a:solidFill>
         <a:effectLst/>
       </p:bgPr>
@@ -3923,6 +3902,38 @@
         <p:nvPr/>
       </p:nvGrpSpPr>
       <p:grpSpPr/>
+      <p:sp>
+        <p:nvSpPr>
+          <p:cNvPr id="2" name="TextBox 1"/>
+          <p:cNvSpPr txBox="1"/>
+          <p:nvPr/>
+        </p:nvSpPr>
+        <p:spPr>
+          <a:xfrm>
+            <a:off x="731520" y="2057400"/>
+            <a:ext cx="10728655" cy="2400300"/>
+          </a:xfrm>
+          <a:prstGeom prst="rect">
+            <a:avLst/>
+          </a:prstGeom>
+          <a:noFill/>
+        </p:spPr>
+        <p:txBody>
+          <a:bodyPr wrap="square" anchor="ctr"/>
+          <a:lstStyle/>
+          <a:p>
+            <a:pPr algn="ctr"/>
+            <a:r>
+              <a:rPr sz="5200" b="1">
+                <a:solidFill>
+                  <a:srgbClr val="1A1A1A"/>
+                </a:solidFill>
+              </a:rPr>
+              <a:t>Ofertório</a:t>
+            </a:r>
+          </a:p>
+        </p:txBody>
+      </p:sp>
     </p:spTree>
   </p:cSld>
   <p:clrMapOvr>
@@ -3957,8 +3968,8 @@
         </p:nvSpPr>
         <p:spPr>
           <a:xfrm>
-            <a:off x="731520" y="2057400"/>
-            <a:ext cx="10728655" cy="2400300"/>
+            <a:off x="731520" y="731520"/>
+            <a:ext cx="10728655" cy="5394960"/>
           </a:xfrm>
           <a:prstGeom prst="rect">
             <a:avLst/>
@@ -3971,12 +3982,12 @@
           <a:p>
             <a:pPr algn="ctr"/>
             <a:r>
-              <a:rPr sz="5200" b="1">
+              <a:rPr sz="3600" b="1" i="0">
                 <a:solidFill>
                   <a:srgbClr val="1A1A1A"/>
                 </a:solidFill>
               </a:rPr>
-              <a:t>Santo</a:t>
+              <a:t>Miserere mei, Domine. Miserere mei, Domine.</a:t>
             </a:r>
           </a:p>
         </p:txBody>
@@ -4029,13 +4040,12 @@
           <a:p>
             <a:pPr algn="ctr"/>
             <a:r>
-              <a:rPr sz="3600" b="1" i="0">
-                <a:solidFill>
-                  <a:srgbClr val="1A1A1A"/>
+              <a:rPr sz="3200" b="0" i="0">
+                <a:solidFill>
+                  <a:srgbClr val="444444"/>
                 </a:solidFill>
               </a:rPr>
-              <a:t>Santo, Santo, Santo / é o Senhor Deus do universo
-Santo, Santo, Santo / é o Senhor Deus do universo</a:t>
+              <a:t>1. Piedade de mim, ó meu Deus, misericórdia. Na imensidão do amor, purificai-me. Lavai-me todo inteiro do pecado, apagai totalmente minha culpa.</a:t>
             </a:r>
           </a:p>
         </p:txBody>
@@ -4088,13 +4098,12 @@
           <a:p>
             <a:pPr algn="ctr"/>
             <a:r>
-              <a:rPr sz="3200" b="0" i="0">
-                <a:solidFill>
-                  <a:srgbClr val="444444"/>
+              <a:rPr sz="3600" b="1" i="0">
+                <a:solidFill>
+                  <a:srgbClr val="1A1A1A"/>
                 </a:solidFill>
               </a:rPr>
-              <a:t>O céu e a terra / proclamam a vossa glória
-Hosana, Hosana nas alturas</a:t>
+              <a:t>Miserere mei, Domine. Miserere mei, Domine.</a:t>
             </a:r>
           </a:p>
         </p:txBody>
@@ -4147,12 +4156,12 @@
           <a:p>
             <a:pPr algn="ctr"/>
             <a:r>
-              <a:rPr sz="3600" b="1" i="0">
-                <a:solidFill>
-                  <a:srgbClr val="1A1A1A"/>
+              <a:rPr sz="3200" b="0" i="0">
+                <a:solidFill>
+                  <a:srgbClr val="444444"/>
                 </a:solidFill>
               </a:rPr>
-              <a:t>Hosana, Hosana nas alturas</a:t>
+              <a:t>2. Eu reconheço toda a minha iniquidade, o meu pecado está sempre à minha frente. Foi contra vós somente que eu pequei e pratiquei o que é mau aos vossos olhos.</a:t>
             </a:r>
           </a:p>
         </p:txBody>
@@ -4205,13 +4214,12 @@
           <a:p>
             <a:pPr algn="ctr"/>
             <a:r>
-              <a:rPr sz="3200" b="0" i="0">
-                <a:solidFill>
-                  <a:srgbClr val="444444"/>
+              <a:rPr sz="3600" b="1" i="0">
+                <a:solidFill>
+                  <a:srgbClr val="1A1A1A"/>
                 </a:solidFill>
               </a:rPr>
-              <a:t>Bendito o que vem / em nome do Senhor
-Hosana, Hosana nas alturas</a:t>
+              <a:t>Miserere mei, Domine. Miserere mei, Domine.</a:t>
             </a:r>
           </a:p>
         </p:txBody>
@@ -4264,12 +4272,12 @@
           <a:p>
             <a:pPr algn="ctr"/>
             <a:r>
-              <a:rPr sz="3600" b="1" i="0">
-                <a:solidFill>
-                  <a:srgbClr val="1A1A1A"/>
+              <a:rPr sz="3200" b="0" i="0">
+                <a:solidFill>
+                  <a:srgbClr val="444444"/>
                 </a:solidFill>
               </a:rPr>
-              <a:t>Hosana, Hosana nas alturas</a:t>
+              <a:t>3. Criai em mim um coração que seja puro, dai-me de novo um espírito firme. Meu sacrifício é minha alma penitente, não desprezeis um coração arrependido.</a:t>
             </a:r>
           </a:p>
         </p:txBody>
@@ -4346,7 +4354,7 @@
     <p:bg>
       <p:bgPr>
         <a:solidFill>
-          <a:srgbClr val="000000"/>
+          <a:srgbClr val="FAF9F7"/>
         </a:solidFill>
         <a:effectLst/>
       </p:bgPr>
@@ -4358,6 +4366,38 @@
         <p:nvPr/>
       </p:nvGrpSpPr>
       <p:grpSpPr/>
+      <p:sp>
+        <p:nvSpPr>
+          <p:cNvPr id="2" name="TextBox 1"/>
+          <p:cNvSpPr txBox="1"/>
+          <p:nvPr/>
+        </p:nvSpPr>
+        <p:spPr>
+          <a:xfrm>
+            <a:off x="731520" y="731520"/>
+            <a:ext cx="10728655" cy="5394960"/>
+          </a:xfrm>
+          <a:prstGeom prst="rect">
+            <a:avLst/>
+          </a:prstGeom>
+          <a:noFill/>
+        </p:spPr>
+        <p:txBody>
+          <a:bodyPr wrap="square" anchor="ctr"/>
+          <a:lstStyle/>
+          <a:p>
+            <a:pPr algn="ctr"/>
+            <a:r>
+              <a:rPr sz="3600" b="1" i="0">
+                <a:solidFill>
+                  <a:srgbClr val="1A1A1A"/>
+                </a:solidFill>
+              </a:rPr>
+              <a:t>Miserere mei, Domine. Miserere mei, Domine.</a:t>
+            </a:r>
+          </a:p>
+        </p:txBody>
+      </p:sp>
     </p:spTree>
   </p:cSld>
   <p:clrMapOvr>
@@ -4372,7 +4412,7 @@
     <p:bg>
       <p:bgPr>
         <a:solidFill>
-          <a:srgbClr val="FAF9F7"/>
+          <a:srgbClr val="000000"/>
         </a:solidFill>
         <a:effectLst/>
       </p:bgPr>
@@ -4384,38 +4424,6 @@
         <p:nvPr/>
       </p:nvGrpSpPr>
       <p:grpSpPr/>
-      <p:sp>
-        <p:nvSpPr>
-          <p:cNvPr id="2" name="TextBox 1"/>
-          <p:cNvSpPr txBox="1"/>
-          <p:nvPr/>
-        </p:nvSpPr>
-        <p:spPr>
-          <a:xfrm>
-            <a:off x="731520" y="2057400"/>
-            <a:ext cx="10728655" cy="2400300"/>
-          </a:xfrm>
-          <a:prstGeom prst="rect">
-            <a:avLst/>
-          </a:prstGeom>
-          <a:noFill/>
-        </p:spPr>
-        <p:txBody>
-          <a:bodyPr wrap="square" anchor="ctr"/>
-          <a:lstStyle/>
-          <a:p>
-            <a:pPr algn="ctr"/>
-            <a:r>
-              <a:rPr sz="5200" b="1">
-                <a:solidFill>
-                  <a:srgbClr val="1A1A1A"/>
-                </a:solidFill>
-              </a:rPr>
-              <a:t>Cordeiro</a:t>
-            </a:r>
-          </a:p>
-        </p:txBody>
-      </p:sp>
     </p:spTree>
   </p:cSld>
   <p:clrMapOvr>
@@ -4450,8 +4458,8 @@
         </p:nvSpPr>
         <p:spPr>
           <a:xfrm>
-            <a:off x="731520" y="731520"/>
-            <a:ext cx="10728655" cy="5394960"/>
+            <a:off x="731520" y="2057400"/>
+            <a:ext cx="10728655" cy="2400300"/>
           </a:xfrm>
           <a:prstGeom prst="rect">
             <a:avLst/>
@@ -4464,12 +4472,12 @@
           <a:p>
             <a:pPr algn="ctr"/>
             <a:r>
-              <a:rPr sz="3200" b="0" i="0">
-                <a:solidFill>
-                  <a:srgbClr val="444444"/>
+              <a:rPr sz="5200" b="1">
+                <a:solidFill>
+                  <a:srgbClr val="1A1A1A"/>
                 </a:solidFill>
               </a:rPr>
-              <a:t>Cordeiro de Deus, que tirais o pecado do mundo</a:t>
+              <a:t>Santo</a:t>
             </a:r>
           </a:p>
         </p:txBody>
@@ -4527,7 +4535,8 @@
                   <a:srgbClr val="1A1A1A"/>
                 </a:solidFill>
               </a:rPr>
-              <a:t>Tende piedade, piedade de nós.</a:t>
+              <a:t>Santo, Santo, Santo / é o Senhor Deus do universo
+Santo, Santo, Santo / é o Senhor Deus do universo</a:t>
             </a:r>
           </a:p>
         </p:txBody>
@@ -4585,7 +4594,8 @@
                   <a:srgbClr val="444444"/>
                 </a:solidFill>
               </a:rPr>
-              <a:t>Cordeiro de Deus, que tirais o peca.do do mundo</a:t>
+              <a:t>O céu e a terra / proclamam a vossa glória
+Hosana, Hosana nas alturas</a:t>
             </a:r>
           </a:p>
         </p:txBody>
@@ -4643,7 +4653,7 @@
                   <a:srgbClr val="1A1A1A"/>
                 </a:solidFill>
               </a:rPr>
-              <a:t>Tende piedade, piedade de nós.</a:t>
+              <a:t>Hosana, Hosana nas alturas</a:t>
             </a:r>
           </a:p>
         </p:txBody>
@@ -4701,7 +4711,8 @@
                   <a:srgbClr val="444444"/>
                 </a:solidFill>
               </a:rPr>
-              <a:t>Cordeiro de Deus, que tirais. o pecado do mundo</a:t>
+              <a:t>Bendito o que vem / em nome do Senhor
+Hosana, Hosana nas alturas</a:t>
             </a:r>
           </a:p>
         </p:txBody>
@@ -4759,7 +4770,7 @@
                   <a:srgbClr val="1A1A1A"/>
                 </a:solidFill>
               </a:rPr>
-              <a:t>Dai-nos a paz, dai-nos a paz</a:t>
+              <a:t>Hosana, Hosana nas alturas</a:t>
             </a:r>
           </a:p>
         </p:txBody>
@@ -4843,7 +4854,7 @@
                   <a:srgbClr val="1A1A1A"/>
                 </a:solidFill>
               </a:rPr>
-              <a:t>Comunhão</a:t>
+              <a:t>Cordeiro</a:t>
             </a:r>
           </a:p>
         </p:txBody>
@@ -4954,12 +4965,12 @@
           <a:p>
             <a:pPr algn="ctr"/>
             <a:r>
-              <a:rPr sz="3600" b="1" i="0">
-                <a:solidFill>
-                  <a:srgbClr val="1A1A1A"/>
+              <a:rPr sz="3200" b="0" i="0">
+                <a:solidFill>
+                  <a:srgbClr val="444444"/>
                 </a:solidFill>
               </a:rPr>
-              <a:t>Não sou eu que vivo, mas Cristo vive em mim, o meu Senhor que me amou doando a sua vida por mim.</a:t>
+              <a:t>Cordeiro de Deus, que tirais o pecado do mundo</a:t>
             </a:r>
           </a:p>
         </p:txBody>
@@ -5012,12 +5023,12 @@
           <a:p>
             <a:pPr algn="ctr"/>
             <a:r>
-              <a:rPr sz="3200" b="0" i="0">
-                <a:solidFill>
-                  <a:srgbClr val="444444"/>
+              <a:rPr sz="3600" b="1" i="0">
+                <a:solidFill>
+                  <a:srgbClr val="1A1A1A"/>
                 </a:solidFill>
               </a:rPr>
-              <a:t>1. Está minha vida crucificada com Cristo, meu Senhor, minha vida que agora vivo escondida está Nele.2. Com Ele morto e ressuscitado pra sempre, na alegria, redimido, sinto o Espírito viver em mim.</a:t>
+              <a:t>Tende piedade, piedade de nós.</a:t>
             </a:r>
           </a:p>
         </p:txBody>
@@ -5070,12 +5081,12 @@
           <a:p>
             <a:pPr algn="ctr"/>
             <a:r>
-              <a:rPr sz="3600" b="1" i="0">
-                <a:solidFill>
-                  <a:srgbClr val="1A1A1A"/>
+              <a:rPr sz="3200" b="0" i="0">
+                <a:solidFill>
+                  <a:srgbClr val="444444"/>
                 </a:solidFill>
               </a:rPr>
-              <a:t>Não sou eu que vivo, mas Cristo vive em mim, o meu Senhor que me amou doando a sua vida por mim.</a:t>
+              <a:t>Cordeiro de Deus, que tirais o peca.do do mundo</a:t>
             </a:r>
           </a:p>
         </p:txBody>
@@ -5094,7 +5105,7 @@
     <p:bg>
       <p:bgPr>
         <a:solidFill>
-          <a:srgbClr val="000000"/>
+          <a:srgbClr val="FAF9F7"/>
         </a:solidFill>
         <a:effectLst/>
       </p:bgPr>
@@ -5106,6 +5117,38 @@
         <p:nvPr/>
       </p:nvGrpSpPr>
       <p:grpSpPr/>
+      <p:sp>
+        <p:nvSpPr>
+          <p:cNvPr id="2" name="TextBox 1"/>
+          <p:cNvSpPr txBox="1"/>
+          <p:nvPr/>
+        </p:nvSpPr>
+        <p:spPr>
+          <a:xfrm>
+            <a:off x="731520" y="731520"/>
+            <a:ext cx="10728655" cy="5394960"/>
+          </a:xfrm>
+          <a:prstGeom prst="rect">
+            <a:avLst/>
+          </a:prstGeom>
+          <a:noFill/>
+        </p:spPr>
+        <p:txBody>
+          <a:bodyPr wrap="square" anchor="ctr"/>
+          <a:lstStyle/>
+          <a:p>
+            <a:pPr algn="ctr"/>
+            <a:r>
+              <a:rPr sz="3600" b="1" i="0">
+                <a:solidFill>
+                  <a:srgbClr val="1A1A1A"/>
+                </a:solidFill>
+              </a:rPr>
+              <a:t>Tende piedade, piedade de nós.</a:t>
+            </a:r>
+          </a:p>
+        </p:txBody>
+      </p:sp>
     </p:spTree>
   </p:cSld>
   <p:clrMapOvr>
@@ -5140,8 +5183,8 @@
         </p:nvSpPr>
         <p:spPr>
           <a:xfrm>
-            <a:off x="731520" y="2057400"/>
-            <a:ext cx="10728655" cy="2400300"/>
+            <a:off x="731520" y="731520"/>
+            <a:ext cx="10728655" cy="5394960"/>
           </a:xfrm>
           <a:prstGeom prst="rect">
             <a:avLst/>
@@ -5154,12 +5197,12 @@
           <a:p>
             <a:pPr algn="ctr"/>
             <a:r>
-              <a:rPr sz="5200" b="1">
-                <a:solidFill>
-                  <a:srgbClr val="1A1A1A"/>
+              <a:rPr sz="3200" b="0" i="0">
+                <a:solidFill>
+                  <a:srgbClr val="444444"/>
                 </a:solidFill>
               </a:rPr>
-              <a:t>Final</a:t>
+              <a:t>Cordeiro de Deus, que tirais. o pecado do mundo</a:t>
             </a:r>
           </a:p>
         </p:txBody>
@@ -5217,7 +5260,7 @@
                   <a:srgbClr val="1A1A1A"/>
                 </a:solidFill>
               </a:rPr>
-              <a:t>Quando Israel saiu do Egito, a casa de Jacó era um povo bárbaro, Judá tornou-se o seu santuário, Israel seu domínio.</a:t>
+              <a:t>Dai-nos a paz, dai-nos a paz</a:t>
             </a:r>
           </a:p>
         </p:txBody>
@@ -5236,7 +5279,7 @@
     <p:bg>
       <p:bgPr>
         <a:solidFill>
-          <a:srgbClr val="FAF9F7"/>
+          <a:srgbClr val="000000"/>
         </a:solidFill>
         <a:effectLst/>
       </p:bgPr>
@@ -5248,38 +5291,6 @@
         <p:nvPr/>
       </p:nvGrpSpPr>
       <p:grpSpPr/>
-      <p:sp>
-        <p:nvSpPr>
-          <p:cNvPr id="2" name="TextBox 1"/>
-          <p:cNvSpPr txBox="1"/>
-          <p:nvPr/>
-        </p:nvSpPr>
-        <p:spPr>
-          <a:xfrm>
-            <a:off x="731520" y="731520"/>
-            <a:ext cx="10728655" cy="5394960"/>
-          </a:xfrm>
-          <a:prstGeom prst="rect">
-            <a:avLst/>
-          </a:prstGeom>
-          <a:noFill/>
-        </p:spPr>
-        <p:txBody>
-          <a:bodyPr wrap="square" anchor="ctr"/>
-          <a:lstStyle/>
-          <a:p>
-            <a:pPr algn="ctr"/>
-            <a:r>
-              <a:rPr sz="3200" b="0" i="0">
-                <a:solidFill>
-                  <a:srgbClr val="444444"/>
-                </a:solidFill>
-              </a:rPr>
-              <a:t>O mar viu e se retirou, o Jordão voltou atrás, os montes saltaram como carneiros, as colinas como um rebanho.</a:t>
-            </a:r>
-          </a:p>
-        </p:txBody>
-      </p:sp>
     </p:spTree>
   </p:cSld>
   <p:clrMapOvr>
@@ -5314,8 +5325,8 @@
         </p:nvSpPr>
         <p:spPr>
           <a:xfrm>
-            <a:off x="731520" y="731520"/>
-            <a:ext cx="10728655" cy="5394960"/>
+            <a:off x="731520" y="2057400"/>
+            <a:ext cx="10728655" cy="2400300"/>
           </a:xfrm>
           <a:prstGeom prst="rect">
             <a:avLst/>
@@ -5328,12 +5339,12 @@
           <a:p>
             <a:pPr algn="ctr"/>
             <a:r>
-              <a:rPr sz="3600" b="1" i="0">
+              <a:rPr sz="5200" b="1">
                 <a:solidFill>
                   <a:srgbClr val="1A1A1A"/>
                 </a:solidFill>
               </a:rPr>
-              <a:t>Quando Israel saiu do Egito, a casa de Jacó era um povo bárbaro, Judá tornou-se o seu santuário, Israel seu domínio.</a:t>
+              <a:t>Comunhão</a:t>
             </a:r>
           </a:p>
         </p:txBody>
@@ -5386,12 +5397,12 @@
           <a:p>
             <a:pPr algn="ctr"/>
             <a:r>
-              <a:rPr sz="3200" b="0" i="0">
-                <a:solidFill>
-                  <a:srgbClr val="444444"/>
+              <a:rPr sz="3600" b="1" i="0">
+                <a:solidFill>
+                  <a:srgbClr val="1A1A1A"/>
                 </a:solidFill>
               </a:rPr>
-              <a:t>O que tem, mar, para fugir? E tu, Jordão, por que voltas? Por que vós, montes, saltam como um cordeiro no rebanho?</a:t>
+              <a:t>Não sou eu que vivo, mas Cristo vive em mim, o meu Senhor que me amou doando a sua vida por mim.</a:t>
             </a:r>
           </a:p>
         </p:txBody>
@@ -5444,12 +5455,12 @@
           <a:p>
             <a:pPr algn="ctr"/>
             <a:r>
-              <a:rPr sz="3600" b="1" i="0">
-                <a:solidFill>
-                  <a:srgbClr val="1A1A1A"/>
+              <a:rPr sz="3200" b="0" i="0">
+                <a:solidFill>
+                  <a:srgbClr val="444444"/>
                 </a:solidFill>
               </a:rPr>
-              <a:t>Quando Israel saiu do Egito, a casa de Jacó era um povo bárbaro, Judá tornou-se o seu santuário, Israel seu domínio.</a:t>
+              <a:t>1. Está minha vida crucificada com Cristo, meu Senhor, minha vida que agora vivo escondida está Nele.</a:t>
             </a:r>
           </a:p>
         </p:txBody>
@@ -5507,7 +5518,7 @@
                   <a:srgbClr val="444444"/>
                 </a:solidFill>
               </a:rPr>
-              <a:t>1.Feliz o homem limpo de toda culpa, no coração é apagado o pecado.2.Eu revelei toda a minha culpa, iniquidade e pecado confesso.3.És meu refúgio, me livra da angústia, me cerca de cantos de libertação.</a:t>
+              <a:t>1. Feliz o homem limpo de toda culpa, no coração é apagado o pecado.</a:t>
             </a:r>
           </a:p>
         </p:txBody>
@@ -5560,12 +5571,12 @@
           <a:p>
             <a:pPr algn="ctr"/>
             <a:r>
-              <a:rPr sz="3200" b="0" i="0">
-                <a:solidFill>
-                  <a:srgbClr val="444444"/>
+              <a:rPr sz="3600" b="1" i="0">
+                <a:solidFill>
+                  <a:srgbClr val="1A1A1A"/>
                 </a:solidFill>
               </a:rPr>
-              <a:t>Trema, ó terra, diante do Senhor, diante do Deus de Jacó, que muda o abismo em lago, a rocha em fonte de água.</a:t>
+              <a:t>Não sou eu que vivo, mas Cristo vive em mim, o meu Senhor que me amou doando a sua vida por mim.</a:t>
             </a:r>
           </a:p>
         </p:txBody>
@@ -5618,6 +5629,438 @@
           <a:p>
             <a:pPr algn="ctr"/>
             <a:r>
+              <a:rPr sz="3200" b="0" i="0">
+                <a:solidFill>
+                  <a:srgbClr val="444444"/>
+                </a:solidFill>
+              </a:rPr>
+              <a:t>2. Com Ele morto e ressuscitado pra sempre, na alegria, redimido, sinto o Espírito viver em mim.</a:t>
+            </a:r>
+          </a:p>
+        </p:txBody>
+      </p:sp>
+    </p:spTree>
+  </p:cSld>
+  <p:clrMapOvr>
+    <a:masterClrMapping/>
+  </p:clrMapOvr>
+</p:sld>
+</file>
+
+<file path=ppt/slides/slide52.xml><?xml version="1.0" encoding="utf-8"?>
+<p:sld xmlns:a="http://schemas.openxmlformats.org/drawingml/2006/main" xmlns:p="http://schemas.openxmlformats.org/presentationml/2006/main" xmlns:r="http://schemas.openxmlformats.org/officeDocument/2006/relationships">
+  <p:cSld>
+    <p:bg>
+      <p:bgPr>
+        <a:solidFill>
+          <a:srgbClr val="FAF9F7"/>
+        </a:solidFill>
+        <a:effectLst/>
+      </p:bgPr>
+    </p:bg>
+    <p:spTree>
+      <p:nvGrpSpPr>
+        <p:cNvPr id="1" name=""/>
+        <p:cNvGrpSpPr/>
+        <p:nvPr/>
+      </p:nvGrpSpPr>
+      <p:grpSpPr/>
+      <p:sp>
+        <p:nvSpPr>
+          <p:cNvPr id="2" name="TextBox 1"/>
+          <p:cNvSpPr txBox="1"/>
+          <p:nvPr/>
+        </p:nvSpPr>
+        <p:spPr>
+          <a:xfrm>
+            <a:off x="731520" y="731520"/>
+            <a:ext cx="10728655" cy="5394960"/>
+          </a:xfrm>
+          <a:prstGeom prst="rect">
+            <a:avLst/>
+          </a:prstGeom>
+          <a:noFill/>
+        </p:spPr>
+        <p:txBody>
+          <a:bodyPr wrap="square" anchor="ctr"/>
+          <a:lstStyle/>
+          <a:p>
+            <a:pPr algn="ctr"/>
+            <a:r>
+              <a:rPr sz="3600" b="1" i="0">
+                <a:solidFill>
+                  <a:srgbClr val="1A1A1A"/>
+                </a:solidFill>
+              </a:rPr>
+              <a:t>Não sou eu que vivo, mas Cristo vive em mim, o meu Senhor que me amou doando a sua vida por mim.</a:t>
+            </a:r>
+          </a:p>
+        </p:txBody>
+      </p:sp>
+    </p:spTree>
+  </p:cSld>
+  <p:clrMapOvr>
+    <a:masterClrMapping/>
+  </p:clrMapOvr>
+</p:sld>
+</file>
+
+<file path=ppt/slides/slide53.xml><?xml version="1.0" encoding="utf-8"?>
+<p:sld xmlns:a="http://schemas.openxmlformats.org/drawingml/2006/main" xmlns:p="http://schemas.openxmlformats.org/presentationml/2006/main" xmlns:r="http://schemas.openxmlformats.org/officeDocument/2006/relationships">
+  <p:cSld>
+    <p:bg>
+      <p:bgPr>
+        <a:solidFill>
+          <a:srgbClr val="000000"/>
+        </a:solidFill>
+        <a:effectLst/>
+      </p:bgPr>
+    </p:bg>
+    <p:spTree>
+      <p:nvGrpSpPr>
+        <p:cNvPr id="1" name=""/>
+        <p:cNvGrpSpPr/>
+        <p:nvPr/>
+      </p:nvGrpSpPr>
+      <p:grpSpPr/>
+    </p:spTree>
+  </p:cSld>
+  <p:clrMapOvr>
+    <a:masterClrMapping/>
+  </p:clrMapOvr>
+</p:sld>
+</file>
+
+<file path=ppt/slides/slide54.xml><?xml version="1.0" encoding="utf-8"?>
+<p:sld xmlns:a="http://schemas.openxmlformats.org/drawingml/2006/main" xmlns:p="http://schemas.openxmlformats.org/presentationml/2006/main" xmlns:r="http://schemas.openxmlformats.org/officeDocument/2006/relationships">
+  <p:cSld>
+    <p:bg>
+      <p:bgPr>
+        <a:solidFill>
+          <a:srgbClr val="FAF9F7"/>
+        </a:solidFill>
+        <a:effectLst/>
+      </p:bgPr>
+    </p:bg>
+    <p:spTree>
+      <p:nvGrpSpPr>
+        <p:cNvPr id="1" name=""/>
+        <p:cNvGrpSpPr/>
+        <p:nvPr/>
+      </p:nvGrpSpPr>
+      <p:grpSpPr/>
+      <p:sp>
+        <p:nvSpPr>
+          <p:cNvPr id="2" name="TextBox 1"/>
+          <p:cNvSpPr txBox="1"/>
+          <p:nvPr/>
+        </p:nvSpPr>
+        <p:spPr>
+          <a:xfrm>
+            <a:off x="731520" y="2057400"/>
+            <a:ext cx="10728655" cy="2400300"/>
+          </a:xfrm>
+          <a:prstGeom prst="rect">
+            <a:avLst/>
+          </a:prstGeom>
+          <a:noFill/>
+        </p:spPr>
+        <p:txBody>
+          <a:bodyPr wrap="square" anchor="ctr"/>
+          <a:lstStyle/>
+          <a:p>
+            <a:pPr algn="ctr"/>
+            <a:r>
+              <a:rPr sz="5200" b="1">
+                <a:solidFill>
+                  <a:srgbClr val="1A1A1A"/>
+                </a:solidFill>
+              </a:rPr>
+              <a:t>Final</a:t>
+            </a:r>
+          </a:p>
+        </p:txBody>
+      </p:sp>
+    </p:spTree>
+  </p:cSld>
+  <p:clrMapOvr>
+    <a:masterClrMapping/>
+  </p:clrMapOvr>
+</p:sld>
+</file>
+
+<file path=ppt/slides/slide55.xml><?xml version="1.0" encoding="utf-8"?>
+<p:sld xmlns:a="http://schemas.openxmlformats.org/drawingml/2006/main" xmlns:p="http://schemas.openxmlformats.org/presentationml/2006/main" xmlns:r="http://schemas.openxmlformats.org/officeDocument/2006/relationships">
+  <p:cSld>
+    <p:bg>
+      <p:bgPr>
+        <a:solidFill>
+          <a:srgbClr val="FAF9F7"/>
+        </a:solidFill>
+        <a:effectLst/>
+      </p:bgPr>
+    </p:bg>
+    <p:spTree>
+      <p:nvGrpSpPr>
+        <p:cNvPr id="1" name=""/>
+        <p:cNvGrpSpPr/>
+        <p:nvPr/>
+      </p:nvGrpSpPr>
+      <p:grpSpPr/>
+      <p:sp>
+        <p:nvSpPr>
+          <p:cNvPr id="2" name="TextBox 1"/>
+          <p:cNvSpPr txBox="1"/>
+          <p:nvPr/>
+        </p:nvSpPr>
+        <p:spPr>
+          <a:xfrm>
+            <a:off x="731520" y="731520"/>
+            <a:ext cx="10728655" cy="5394960"/>
+          </a:xfrm>
+          <a:prstGeom prst="rect">
+            <a:avLst/>
+          </a:prstGeom>
+          <a:noFill/>
+        </p:spPr>
+        <p:txBody>
+          <a:bodyPr wrap="square" anchor="ctr"/>
+          <a:lstStyle/>
+          <a:p>
+            <a:pPr algn="ctr"/>
+            <a:r>
+              <a:rPr sz="3600" b="1" i="0">
+                <a:solidFill>
+                  <a:srgbClr val="1A1A1A"/>
+                </a:solidFill>
+              </a:rPr>
+              <a:t>Quando Israel saiu do Egito, a casa de Jacó era um povo bárbaro, Judá tornou-se o seu santuário, Israel seu domínio.</a:t>
+            </a:r>
+          </a:p>
+        </p:txBody>
+      </p:sp>
+    </p:spTree>
+  </p:cSld>
+  <p:clrMapOvr>
+    <a:masterClrMapping/>
+  </p:clrMapOvr>
+</p:sld>
+</file>
+
+<file path=ppt/slides/slide56.xml><?xml version="1.0" encoding="utf-8"?>
+<p:sld xmlns:a="http://schemas.openxmlformats.org/drawingml/2006/main" xmlns:p="http://schemas.openxmlformats.org/presentationml/2006/main" xmlns:r="http://schemas.openxmlformats.org/officeDocument/2006/relationships">
+  <p:cSld>
+    <p:bg>
+      <p:bgPr>
+        <a:solidFill>
+          <a:srgbClr val="FAF9F7"/>
+        </a:solidFill>
+        <a:effectLst/>
+      </p:bgPr>
+    </p:bg>
+    <p:spTree>
+      <p:nvGrpSpPr>
+        <p:cNvPr id="1" name=""/>
+        <p:cNvGrpSpPr/>
+        <p:nvPr/>
+      </p:nvGrpSpPr>
+      <p:grpSpPr/>
+      <p:sp>
+        <p:nvSpPr>
+          <p:cNvPr id="2" name="TextBox 1"/>
+          <p:cNvSpPr txBox="1"/>
+          <p:nvPr/>
+        </p:nvSpPr>
+        <p:spPr>
+          <a:xfrm>
+            <a:off x="731520" y="731520"/>
+            <a:ext cx="10728655" cy="5394960"/>
+          </a:xfrm>
+          <a:prstGeom prst="rect">
+            <a:avLst/>
+          </a:prstGeom>
+          <a:noFill/>
+        </p:spPr>
+        <p:txBody>
+          <a:bodyPr wrap="square" anchor="ctr"/>
+          <a:lstStyle/>
+          <a:p>
+            <a:pPr algn="ctr"/>
+            <a:r>
+              <a:rPr sz="3200" b="0" i="0">
+                <a:solidFill>
+                  <a:srgbClr val="444444"/>
+                </a:solidFill>
+              </a:rPr>
+              <a:t>O mar viu e se retirou, o Jordão voltou atrás, os montes saltaram como carneiros, as colinas como um rebanho.</a:t>
+            </a:r>
+          </a:p>
+        </p:txBody>
+      </p:sp>
+    </p:spTree>
+  </p:cSld>
+  <p:clrMapOvr>
+    <a:masterClrMapping/>
+  </p:clrMapOvr>
+</p:sld>
+</file>
+
+<file path=ppt/slides/slide57.xml><?xml version="1.0" encoding="utf-8"?>
+<p:sld xmlns:a="http://schemas.openxmlformats.org/drawingml/2006/main" xmlns:p="http://schemas.openxmlformats.org/presentationml/2006/main" xmlns:r="http://schemas.openxmlformats.org/officeDocument/2006/relationships">
+  <p:cSld>
+    <p:bg>
+      <p:bgPr>
+        <a:solidFill>
+          <a:srgbClr val="FAF9F7"/>
+        </a:solidFill>
+        <a:effectLst/>
+      </p:bgPr>
+    </p:bg>
+    <p:spTree>
+      <p:nvGrpSpPr>
+        <p:cNvPr id="1" name=""/>
+        <p:cNvGrpSpPr/>
+        <p:nvPr/>
+      </p:nvGrpSpPr>
+      <p:grpSpPr/>
+      <p:sp>
+        <p:nvSpPr>
+          <p:cNvPr id="2" name="TextBox 1"/>
+          <p:cNvSpPr txBox="1"/>
+          <p:nvPr/>
+        </p:nvSpPr>
+        <p:spPr>
+          <a:xfrm>
+            <a:off x="731520" y="731520"/>
+            <a:ext cx="10728655" cy="5394960"/>
+          </a:xfrm>
+          <a:prstGeom prst="rect">
+            <a:avLst/>
+          </a:prstGeom>
+          <a:noFill/>
+        </p:spPr>
+        <p:txBody>
+          <a:bodyPr wrap="square" anchor="ctr"/>
+          <a:lstStyle/>
+          <a:p>
+            <a:pPr algn="ctr"/>
+            <a:r>
+              <a:rPr sz="3600" b="1" i="0">
+                <a:solidFill>
+                  <a:srgbClr val="1A1A1A"/>
+                </a:solidFill>
+              </a:rPr>
+              <a:t>Quando Israel saiu do Egito, a casa de Jacó era um povo bárbaro, Judá tornou-se o seu santuário, Israel seu domínio.</a:t>
+            </a:r>
+          </a:p>
+        </p:txBody>
+      </p:sp>
+    </p:spTree>
+  </p:cSld>
+  <p:clrMapOvr>
+    <a:masterClrMapping/>
+  </p:clrMapOvr>
+</p:sld>
+</file>
+
+<file path=ppt/slides/slide58.xml><?xml version="1.0" encoding="utf-8"?>
+<p:sld xmlns:a="http://schemas.openxmlformats.org/drawingml/2006/main" xmlns:p="http://schemas.openxmlformats.org/presentationml/2006/main" xmlns:r="http://schemas.openxmlformats.org/officeDocument/2006/relationships">
+  <p:cSld>
+    <p:bg>
+      <p:bgPr>
+        <a:solidFill>
+          <a:srgbClr val="FAF9F7"/>
+        </a:solidFill>
+        <a:effectLst/>
+      </p:bgPr>
+    </p:bg>
+    <p:spTree>
+      <p:nvGrpSpPr>
+        <p:cNvPr id="1" name=""/>
+        <p:cNvGrpSpPr/>
+        <p:nvPr/>
+      </p:nvGrpSpPr>
+      <p:grpSpPr/>
+      <p:sp>
+        <p:nvSpPr>
+          <p:cNvPr id="2" name="TextBox 1"/>
+          <p:cNvSpPr txBox="1"/>
+          <p:nvPr/>
+        </p:nvSpPr>
+        <p:spPr>
+          <a:xfrm>
+            <a:off x="731520" y="731520"/>
+            <a:ext cx="10728655" cy="5394960"/>
+          </a:xfrm>
+          <a:prstGeom prst="rect">
+            <a:avLst/>
+          </a:prstGeom>
+          <a:noFill/>
+        </p:spPr>
+        <p:txBody>
+          <a:bodyPr wrap="square" anchor="ctr"/>
+          <a:lstStyle/>
+          <a:p>
+            <a:pPr algn="ctr"/>
+            <a:r>
+              <a:rPr sz="3200" b="0" i="0">
+                <a:solidFill>
+                  <a:srgbClr val="444444"/>
+                </a:solidFill>
+              </a:rPr>
+              <a:t>O que tem, mar, para fugir? E tu, Jordão, por que voltas? Por que vós, montes, saltam como um cordeiro no rebanho?</a:t>
+            </a:r>
+          </a:p>
+        </p:txBody>
+      </p:sp>
+    </p:spTree>
+  </p:cSld>
+  <p:clrMapOvr>
+    <a:masterClrMapping/>
+  </p:clrMapOvr>
+</p:sld>
+</file>
+
+<file path=ppt/slides/slide59.xml><?xml version="1.0" encoding="utf-8"?>
+<p:sld xmlns:a="http://schemas.openxmlformats.org/drawingml/2006/main" xmlns:p="http://schemas.openxmlformats.org/presentationml/2006/main" xmlns:r="http://schemas.openxmlformats.org/officeDocument/2006/relationships">
+  <p:cSld>
+    <p:bg>
+      <p:bgPr>
+        <a:solidFill>
+          <a:srgbClr val="FAF9F7"/>
+        </a:solidFill>
+        <a:effectLst/>
+      </p:bgPr>
+    </p:bg>
+    <p:spTree>
+      <p:nvGrpSpPr>
+        <p:cNvPr id="1" name=""/>
+        <p:cNvGrpSpPr/>
+        <p:nvPr/>
+      </p:nvGrpSpPr>
+      <p:grpSpPr/>
+      <p:sp>
+        <p:nvSpPr>
+          <p:cNvPr id="2" name="TextBox 1"/>
+          <p:cNvSpPr txBox="1"/>
+          <p:nvPr/>
+        </p:nvSpPr>
+        <p:spPr>
+          <a:xfrm>
+            <a:off x="731520" y="731520"/>
+            <a:ext cx="10728655" cy="5394960"/>
+          </a:xfrm>
+          <a:prstGeom prst="rect">
+            <a:avLst/>
+          </a:prstGeom>
+          <a:noFill/>
+        </p:spPr>
+        <p:txBody>
+          <a:bodyPr wrap="square" anchor="ctr"/>
+          <a:lstStyle/>
+          <a:p>
+            <a:pPr algn="ctr"/>
+            <a:r>
               <a:rPr sz="3600" b="1" i="0">
                 <a:solidFill>
                   <a:srgbClr val="1A1A1A"/>
@@ -5694,13 +6137,129 @@
 </p:sld>
 </file>
 
+<file path=ppt/slides/slide60.xml><?xml version="1.0" encoding="utf-8"?>
+<p:sld xmlns:a="http://schemas.openxmlformats.org/drawingml/2006/main" xmlns:p="http://schemas.openxmlformats.org/presentationml/2006/main" xmlns:r="http://schemas.openxmlformats.org/officeDocument/2006/relationships">
+  <p:cSld>
+    <p:bg>
+      <p:bgPr>
+        <a:solidFill>
+          <a:srgbClr val="FAF9F7"/>
+        </a:solidFill>
+        <a:effectLst/>
+      </p:bgPr>
+    </p:bg>
+    <p:spTree>
+      <p:nvGrpSpPr>
+        <p:cNvPr id="1" name=""/>
+        <p:cNvGrpSpPr/>
+        <p:nvPr/>
+      </p:nvGrpSpPr>
+      <p:grpSpPr/>
+      <p:sp>
+        <p:nvSpPr>
+          <p:cNvPr id="2" name="TextBox 1"/>
+          <p:cNvSpPr txBox="1"/>
+          <p:nvPr/>
+        </p:nvSpPr>
+        <p:spPr>
+          <a:xfrm>
+            <a:off x="731520" y="731520"/>
+            <a:ext cx="10728655" cy="5394960"/>
+          </a:xfrm>
+          <a:prstGeom prst="rect">
+            <a:avLst/>
+          </a:prstGeom>
+          <a:noFill/>
+        </p:spPr>
+        <p:txBody>
+          <a:bodyPr wrap="square" anchor="ctr"/>
+          <a:lstStyle/>
+          <a:p>
+            <a:pPr algn="ctr"/>
+            <a:r>
+              <a:rPr sz="3200" b="0" i="0">
+                <a:solidFill>
+                  <a:srgbClr val="444444"/>
+                </a:solidFill>
+              </a:rPr>
+              <a:t>Trema, ó terra, diante do Senhor, diante do Deus de Jacó, que muda o abismo em lago, a rocha em fonte de água.</a:t>
+            </a:r>
+          </a:p>
+        </p:txBody>
+      </p:sp>
+    </p:spTree>
+  </p:cSld>
+  <p:clrMapOvr>
+    <a:masterClrMapping/>
+  </p:clrMapOvr>
+</p:sld>
+</file>
+
+<file path=ppt/slides/slide61.xml><?xml version="1.0" encoding="utf-8"?>
+<p:sld xmlns:a="http://schemas.openxmlformats.org/drawingml/2006/main" xmlns:p="http://schemas.openxmlformats.org/presentationml/2006/main" xmlns:r="http://schemas.openxmlformats.org/officeDocument/2006/relationships">
+  <p:cSld>
+    <p:bg>
+      <p:bgPr>
+        <a:solidFill>
+          <a:srgbClr val="FAF9F7"/>
+        </a:solidFill>
+        <a:effectLst/>
+      </p:bgPr>
+    </p:bg>
+    <p:spTree>
+      <p:nvGrpSpPr>
+        <p:cNvPr id="1" name=""/>
+        <p:cNvGrpSpPr/>
+        <p:nvPr/>
+      </p:nvGrpSpPr>
+      <p:grpSpPr/>
+      <p:sp>
+        <p:nvSpPr>
+          <p:cNvPr id="2" name="TextBox 1"/>
+          <p:cNvSpPr txBox="1"/>
+          <p:nvPr/>
+        </p:nvSpPr>
+        <p:spPr>
+          <a:xfrm>
+            <a:off x="731520" y="731520"/>
+            <a:ext cx="10728655" cy="5394960"/>
+          </a:xfrm>
+          <a:prstGeom prst="rect">
+            <a:avLst/>
+          </a:prstGeom>
+          <a:noFill/>
+        </p:spPr>
+        <p:txBody>
+          <a:bodyPr wrap="square" anchor="ctr"/>
+          <a:lstStyle/>
+          <a:p>
+            <a:pPr algn="ctr"/>
+            <a:r>
+              <a:rPr sz="3600" b="1" i="0">
+                <a:solidFill>
+                  <a:srgbClr val="1A1A1A"/>
+                </a:solidFill>
+              </a:rPr>
+              <a:t>Quando Israel saiu do Egito, a casa de Jacó era um povo bárbaro, Judá tornou-se o seu santuário, Israel seu domínio.</a:t>
+            </a:r>
+          </a:p>
+        </p:txBody>
+      </p:sp>
+    </p:spTree>
+  </p:cSld>
+  <p:clrMapOvr>
+    <a:masterClrMapping/>
+  </p:clrMapOvr>
+</p:sld>
+</file>
+
 <file path=ppt/slides/slide7.xml><?xml version="1.0" encoding="utf-8"?>
 <p:sld xmlns:a="http://schemas.openxmlformats.org/drawingml/2006/main" xmlns:p="http://schemas.openxmlformats.org/presentationml/2006/main" xmlns:r="http://schemas.openxmlformats.org/officeDocument/2006/relationships">
   <p:cSld>
     <p:bg>
       <p:bgPr>
         <a:solidFill>
-          <a:srgbClr val="000000"/>
+          <a:srgbClr val="FAF9F7"/>
         </a:solidFill>
         <a:effectLst/>
       </p:bgPr>
@@ -5712,6 +6271,38 @@
         <p:nvPr/>
       </p:nvGrpSpPr>
       <p:grpSpPr/>
+      <p:sp>
+        <p:nvSpPr>
+          <p:cNvPr id="2" name="TextBox 1"/>
+          <p:cNvSpPr txBox="1"/>
+          <p:nvPr/>
+        </p:nvSpPr>
+        <p:spPr>
+          <a:xfrm>
+            <a:off x="731520" y="731520"/>
+            <a:ext cx="10728655" cy="5394960"/>
+          </a:xfrm>
+          <a:prstGeom prst="rect">
+            <a:avLst/>
+          </a:prstGeom>
+          <a:noFill/>
+        </p:spPr>
+        <p:txBody>
+          <a:bodyPr wrap="square" anchor="ctr"/>
+          <a:lstStyle/>
+          <a:p>
+            <a:pPr algn="ctr"/>
+            <a:r>
+              <a:rPr sz="3200" b="0" i="0">
+                <a:solidFill>
+                  <a:srgbClr val="444444"/>
+                </a:solidFill>
+              </a:rPr>
+              <a:t>2. Eu revelei toda a minha culpa, iniquidade e pecado confesso.</a:t>
+            </a:r>
+          </a:p>
+        </p:txBody>
+      </p:sp>
     </p:spTree>
   </p:cSld>
   <p:clrMapOvr>
@@ -5746,8 +6337,8 @@
         </p:nvSpPr>
         <p:spPr>
           <a:xfrm>
-            <a:off x="731520" y="2057400"/>
-            <a:ext cx="10728655" cy="2400300"/>
+            <a:off x="731520" y="731520"/>
+            <a:ext cx="10728655" cy="5394960"/>
           </a:xfrm>
           <a:prstGeom prst="rect">
             <a:avLst/>
@@ -5760,12 +6351,12 @@
           <a:p>
             <a:pPr algn="ctr"/>
             <a:r>
-              <a:rPr sz="5200" b="1">
+              <a:rPr sz="3600" b="1" i="0">
                 <a:solidFill>
                   <a:srgbClr val="1A1A1A"/>
                 </a:solidFill>
               </a:rPr>
-              <a:t>Ato Penitencial</a:t>
+              <a:t>Feliz aquele a quem o Senhor perdoa o pecado. Feliz aquele a quem o Senhor perdoa o pecado.</a:t>
             </a:r>
           </a:p>
         </p:txBody>
@@ -5823,8 +6414,7 @@
                   <a:srgbClr val="444444"/>
                 </a:solidFill>
               </a:rPr>
-              <a:t>Ó Deus, meu coração renova em mim,
-com teu espírito, o espírito de santidade.</a:t>
+              <a:t>3. És meu refúgio, me livra da angústia, me cerca de cantos de libertação.</a:t>
             </a:r>
           </a:p>
         </p:txBody>

</xml_diff>